<commit_message>
Fix: Regenerar PowerPoint con XML valido (corregir caracteres especiales)
</commit_message>
<xml_diff>
--- a/PRESENTACION_EMERGENCIAS_FERROVIARIAS_COLOMBIA.pptx
+++ b/PRESENTACION_EMERGENCIAS_FERROVIARIAS_COLOMBIA.pptx
@@ -1,6 +1,6 @@
 
 <file path=ppt/presentation.xml><?xml version="1.0" encoding="utf-8"?>
-<p:presentation xmlns:a="http://schemas.openxmlformats.org/drawingml/2006/main" xmlns:r="http://schemas.openxmlformats.org/officeDocument/2006/relationships" xmlns:p="http://schemas.openxmlformats.org/presentationml/2006/main">
+<p:presentation xmlns:a="http://schemas.openxmlformats.org/drawingml/2006/main" xmlns:r="http://schemas.openxmlformats.org/officeDocument/2006/relationships" xmlns:p="http://schemas.openxmlformats.org/presentationml/2006/main" saveSubsetFonts="1">
   <p:sldMasterIdLst>
     <p:sldMasterId id="2147483648" r:id="rId1"/>
   </p:sldMasterIdLst>
@@ -27,7 +27,7 @@
     <p:sldId id="275" r:id="rId22"/>
     <p:sldId id="276" r:id="rId23"/>
   </p:sldIdLst>
-  <p:sldSz cx="12192000" cy="6858000"/>
+  <p:sldSz cx="12192000" cy="6858000" type="screen16x9"/>
   <p:notesSz cx="6858000" cy="12192000"/>
 </p:presentation>
 </file>
@@ -1130,159 +1130,404 @@
 </p:sld>
 </file>
 
-<file path=ppt/slides/slide12.xml><?xml version="1.0" encoding="UTF-8" standalone="yes"?>
-<p:sld xmlns:a="http://schemas.openxmlformats.org/drawingml/2006/main"
-       xmlns:r="http://schemas.openxmlformats.org/officeDocument/2006/relationships"
-       xmlns:p="http://schemas.openxmlformats.org/presentationml/2006/main">
+<file path=ppt/slides/slide12.xml><?xml version="1.0" encoding="utf-8"?>
+<p:sld xmlns:a="http://schemas.openxmlformats.org/drawingml/2006/main" xmlns:r="http://schemas.openxmlformats.org/officeDocument/2006/relationships" xmlns:p="http://schemas.openxmlformats.org/presentationml/2006/main">
   <p:cSld>
     <p:bg>
       <p:bgPr>
-        <a:solidFill><a:srgbClr val="FFFFFF"/></a:solidFill>
+        <a:solidFill>
+          <a:srgbClr val="FFFFFF"/>
+        </a:solidFill>
         <a:effectLst/>
       </p:bgPr>
     </p:bg>
     <p:spTree>
-      <p:nvGrpSpPr><p:cNvPr id="1" name=""/><p:cNvGrpSpPr/><p:nvPr/></p:nvGrpSpPr>
+      <p:nvGrpSpPr>
+        <p:cNvPr id="1" name=""/>
+        <p:cNvGrpSpPr/>
+        <p:nvPr/>
+      </p:nvGrpSpPr>
       <p:grpSpPr/>
       <p:sp>
-  <p:nvSpPr><p:cNvPr id="2" name="Line2"/><p:cNvSpPr/><p:nvPr/></p:nvSpPr>
-  <p:spPr>
-    <a:xfrm><a:off x="0" y="0"/><a:ext cx="12192000" cy="540000"/></a:xfrm>
-    <a:prstGeom prst="rect"><a:avLst/></a:prstGeom>
-    <a:solidFill><a:srgbClr val="1B3A5C"/></a:solidFill>
-    <a:ln w="0"><a:noFill/></a:ln>
-  </p:spPr>
-</p:sp><p:sp>
-  <p:nvSpPr><p:cNvPr id="3" name="TextBox3"/><p:cNvSpPr txBox="1"/><p:nvPr/></p:nvSpPr>
-  <p:spPr>
-    <a:xfrm><a:off x="360000" y="36000"/><a:ext cx="7200000" cy="503999"/></a:xfrm>
-    <a:prstGeom prst="rect"><a:avLst/></a:prstGeom>
-    <a:noFill/>
-  </p:spPr>
-  <p:txBody>
-    <a:bodyPr wrap="square" rtlCol="0"/>
-    <a:lstStyle/>
-    <a:p><a:pPr algn="l"/><a:r><a:rPr lang="es-CO" b="1" dirty="0"><a:solidFill><a:srgbClr val="FFFFFF"/></a:solidFill><a:sz val="1800"/></a:rPr><a:t>MODULO 5</a:t></a:r></a:p>
-
-  </p:txBody>
-</p:sp><p:sp>
-  <p:nvSpPr><p:cNvPr id="4" name="TextBox4"/><p:cNvSpPr txBox="1"/><p:nvPr/></p:nvSpPr>
-  <p:spPr>
-    <a:xfrm><a:off x="360000" y="720000"/><a:ext cx="11520000" cy="540000"/></a:xfrm>
-    <a:prstGeom prst="rect"><a:avLst/></a:prstGeom>
-    <a:noFill/>
-  </p:spPr>
-  <p:txBody>
-    <a:bodyPr wrap="square" rtlCol="0"/>
-    <a:lstStyle/>
-    <a:p><a:pPr algn="ctr"/><a:r><a:rPr lang="es-CO" b="1" dirty="0"><a:solidFill><a:srgbClr val="1B3A5C"/></a:solidFill><a:sz val="2200"/></a:rPr><a:t>TRIAGE START - Clasificacion de Victimas</a:t></a:r></a:p>
-
-  </p:txBody>
-</p:sp><p:sp>
-  <p:nvSpPr><p:cNvPr id="10" name="T0"/><p:cNvSpPr/><p:nvPr/></p:nvSpPr>
-  <p:spPr>
-    <a:xfrm><a:off x="360000" y="1620000"/><a:ext cx="2880000" cy="792000"/></a:xfrm>
-    <a:prstGeom prst="roundRect"><a:avLst><a:gd name="adj" fmla="val 5000"/></a:avLst></a:prstGeom>
-    <a:solidFill><a:srgbClr val="000000"/></a:solidFill>
-    <a:ln w="0"><a:noFill/></a:ln>
-  </p:spPr>
-  <p:txBody>
-    <a:bodyPr anchor="ctr" anchorCtr="1"/>
-    <a:lstStyle/>
-    <a:p><a:pPr algn="ctr"/><a:r><a:rPr lang="es-CO" b="1" dirty="0"><a:solidFill><a:srgbClr val="FFFFFF"/></a:solidFill><a:sz val="1400"/></a:rPr><a:t>NEGRO</a:t></a:r></a:p>
-  </p:txBody>
-</p:sp><p:sp>
-  <p:nvSpPr><p:cNvPr id="20" name="TextBox20"/><p:cNvSpPr txBox="1"/><p:nvPr/></p:nvSpPr>
-  <p:spPr>
-    <a:xfrm><a:off x="3600000" y="1728000"/><a:ext cx="7920000" cy="720000"/></a:xfrm>
-    <a:prstGeom prst="rect"><a:avLst/></a:prstGeom>
-    <a:noFill/>
-  </p:spPr>
-  <p:txBody>
-    <a:bodyPr wrap="square" rtlCol="0"/>
-    <a:lstStyle/>
-    <a:p><a:pPr algn="l"/><a:r><a:rPr lang="es-CO" dirty="0"><a:solidFill><a:srgbClr val="404040"/></a:solidFill><a:sz val="1400"/></a:rPr><a:t>Fallecido - Sin respiracion</a:t></a:r></a:p>
-
-  </p:txBody>
-</p:sp><p:sp>
-  <p:nvSpPr><p:cNvPr id="11" name="T1"/><p:cNvSpPr/><p:nvPr/></p:nvSpPr>
-  <p:spPr>
-    <a:xfrm><a:off x="360000" y="2627999"/><a:ext cx="2880000" cy="792000"/></a:xfrm>
-    <a:prstGeom prst="roundRect"><a:avLst><a:gd name="adj" fmla="val 5000"/></a:avLst></a:prstGeom>
-    <a:solidFill><a:srgbClr val="C00000"/></a:solidFill>
-    <a:ln w="0"><a:noFill/></a:ln>
-  </p:spPr>
-  <p:txBody>
-    <a:bodyPr anchor="ctr" anchorCtr="1"/>
-    <a:lstStyle/>
-    <a:p><a:pPr algn="ctr"/><a:r><a:rPr lang="es-CO" b="1" dirty="0"><a:solidFill><a:srgbClr val="FFFFFF"/></a:solidFill><a:sz val="1400"/></a:rPr><a:t>ROJO</a:t></a:r></a:p>
-  </p:txBody>
-</p:sp><p:sp>
-  <p:nvSpPr><p:cNvPr id="21" name="TextBox21"/><p:cNvSpPr txBox="1"/><p:nvPr/></p:nvSpPr>
-  <p:spPr>
-    <a:xfrm><a:off x="3600000" y="2735999"/><a:ext cx="7920000" cy="720000"/></a:xfrm>
-    <a:prstGeom prst="rect"><a:avLst/></a:prstGeom>
-    <a:noFill/>
-  </p:spPr>
-  <p:txBody>
-    <a:bodyPr wrap="square" rtlCol="0"/>
-    <a:lstStyle/>
-    <a:p><a:pPr algn="l"/><a:r><a:rPr lang="es-CO" dirty="0"><a:solidFill><a:srgbClr val="404040"/></a:solidFill><a:sz val="1400"/></a:rPr><a:t>Inmediato - Riesgo vital < 60 min</a:t></a:r></a:p>
-
-  </p:txBody>
-</p:sp><p:sp>
-  <p:nvSpPr><p:cNvPr id="12" name="T2"/><p:cNvSpPr/><p:nvPr/></p:nvSpPr>
-  <p:spPr>
-    <a:xfrm><a:off x="360000" y="3635998"/><a:ext cx="2880000" cy="792000"/></a:xfrm>
-    <a:prstGeom prst="roundRect"><a:avLst><a:gd name="adj" fmla="val 5000"/></a:avLst></a:prstGeom>
-    <a:solidFill><a:srgbClr val="FFC000"/></a:solidFill>
-    <a:ln w="0"><a:noFill/></a:ln>
-  </p:spPr>
-  <p:txBody>
-    <a:bodyPr anchor="ctr" anchorCtr="1"/>
-    <a:lstStyle/>
-    <a:p><a:pPr algn="ctr"/><a:r><a:rPr lang="es-CO" b="1" dirty="0"><a:solidFill><a:srgbClr val="000000"/></a:solidFill><a:sz val="1400"/></a:rPr><a:t>AMARILLO</a:t></a:r></a:p>
-  </p:txBody>
-</p:sp><p:sp>
-  <p:nvSpPr><p:cNvPr id="22" name="TextBox22"/><p:cNvSpPr txBox="1"/><p:nvPr/></p:nvSpPr>
-  <p:spPr>
-    <a:xfrm><a:off x="3600000" y="3743998"/><a:ext cx="7920000" cy="720000"/></a:xfrm>
-    <a:prstGeom prst="rect"><a:avLst/></a:prstGeom>
-    <a:noFill/>
-  </p:spPr>
-  <p:txBody>
-    <a:bodyPr wrap="square" rtlCol="0"/>
-    <a:lstStyle/>
-    <a:p><a:pPr algn="l"/><a:r><a:rPr lang="es-CO" dirty="0"><a:solidFill><a:srgbClr val="404040"/></a:solidFill><a:sz val="1400"/></a:rPr><a:t>Urgente - Serio pero estable</a:t></a:r></a:p>
-
-  </p:txBody>
-</p:sp><p:sp>
-  <p:nvSpPr><p:cNvPr id="13" name="T3"/><p:cNvSpPr/><p:nvPr/></p:nvSpPr>
-  <p:spPr>
-    <a:xfrm><a:off x="360000" y="4643997"/><a:ext cx="2880000" cy="792000"/></a:xfrm>
-    <a:prstGeom prst="roundRect"><a:avLst><a:gd name="adj" fmla="val 5000"/></a:avLst></a:prstGeom>
-    <a:solidFill><a:srgbClr val="70AD47"/></a:solidFill>
-    <a:ln w="0"><a:noFill/></a:ln>
-  </p:spPr>
-  <p:txBody>
-    <a:bodyPr anchor="ctr" anchorCtr="1"/>
-    <a:lstStyle/>
-    <a:p><a:pPr algn="ctr"/><a:r><a:rPr lang="es-CO" b="1" dirty="0"><a:solidFill><a:srgbClr val="FFFFFF"/></a:solidFill><a:sz val="1400"/></a:rPr><a:t>VERDE</a:t></a:r></a:p>
-  </p:txBody>
-</p:sp><p:sp>
-  <p:nvSpPr><p:cNvPr id="23" name="TextBox23"/><p:cNvSpPr txBox="1"/><p:nvPr/></p:nvSpPr>
-  <p:spPr>
-    <a:xfrm><a:off x="3600000" y="4751997"/><a:ext cx="7920000" cy="720000"/></a:xfrm>
-    <a:prstGeom prst="rect"><a:avLst/></a:prstGeom>
-    <a:noFill/>
-  </p:spPr>
-  <p:txBody>
-    <a:bodyPr wrap="square" rtlCol="0"/>
-    <a:lstStyle/>
-    <a:p><a:pPr algn="l"/><a:r><a:rPr lang="es-CO" dirty="0"><a:solidFill><a:srgbClr val="404040"/></a:solidFill><a:sz val="1400"/></a:rPr><a:t>Menor - Camina, ambulatorio</a:t></a:r></a:p>
-
-  </p:txBody>
-</p:sp>
+        <p:nvSpPr>
+          <p:cNvPr id="2" name="Line2"/>
+          <p:cNvSpPr/>
+          <p:nvPr/>
+        </p:nvSpPr>
+        <p:spPr>
+          <a:xfrm>
+            <a:off x="0" y="0"/>
+            <a:ext cx="12192000" cy="540000"/>
+          </a:xfrm>
+          <a:prstGeom prst="rect">
+            <a:avLst/>
+          </a:prstGeom>
+          <a:solidFill>
+            <a:srgbClr val="1B3A5C"/>
+          </a:solidFill>
+          <a:ln w="0">
+            <a:noFill/>
+          </a:ln>
+        </p:spPr>
+      </p:sp>
+      <p:sp>
+        <p:nvSpPr>
+          <p:cNvPr id="3" name="TextBox3"/>
+          <p:cNvSpPr txBox="1"/>
+          <p:nvPr/>
+        </p:nvSpPr>
+        <p:spPr>
+          <a:xfrm>
+            <a:off x="360000" y="36000"/>
+            <a:ext cx="7200000" cy="503999"/>
+          </a:xfrm>
+          <a:prstGeom prst="rect">
+            <a:avLst/>
+          </a:prstGeom>
+          <a:noFill/>
+        </p:spPr>
+        <p:txBody>
+          <a:bodyPr wrap="square" rtlCol="0"/>
+          <a:lstStyle/>
+          <a:p>
+            <a:pPr algn="l"/>
+            <a:r>
+              <a:rPr lang="es-CO" b="1" dirty="0">
+                <a:solidFill>
+                  <a:srgbClr val="FFFFFF"/>
+                </a:solidFill>
+                <a:sz val="1800"/>
+              </a:rPr>
+              <a:t>MODULO 5</a:t>
+            </a:r>
+          </a:p>
+        </p:txBody>
+      </p:sp>
+      <p:sp>
+        <p:nvSpPr>
+          <p:cNvPr id="4" name="TextBox4"/>
+          <p:cNvSpPr txBox="1"/>
+          <p:nvPr/>
+        </p:nvSpPr>
+        <p:spPr>
+          <a:xfrm>
+            <a:off x="360000" y="720000"/>
+            <a:ext cx="11520000" cy="540000"/>
+          </a:xfrm>
+          <a:prstGeom prst="rect">
+            <a:avLst/>
+          </a:prstGeom>
+          <a:noFill/>
+        </p:spPr>
+        <p:txBody>
+          <a:bodyPr wrap="square" rtlCol="0"/>
+          <a:lstStyle/>
+          <a:p>
+            <a:pPr algn="ctr"/>
+            <a:r>
+              <a:rPr lang="es-CO" b="1" dirty="0">
+                <a:solidFill>
+                  <a:srgbClr val="1B3A5C"/>
+                </a:solidFill>
+                <a:sz val="2200"/>
+              </a:rPr>
+              <a:t>TRIAGE START - Clasificacion de Victimas</a:t>
+            </a:r>
+          </a:p>
+        </p:txBody>
+      </p:sp>
+      <p:sp>
+        <p:nvSpPr>
+          <p:cNvPr id="10" name="T0"/>
+          <p:cNvSpPr/>
+          <p:nvPr/>
+        </p:nvSpPr>
+        <p:spPr>
+          <a:xfrm>
+            <a:off x="360000" y="1620000"/>
+            <a:ext cx="2880000" cy="792000"/>
+          </a:xfrm>
+          <a:prstGeom prst="roundRect">
+            <a:avLst>
+              <a:gd name="adj" fmla="val 5000"/>
+            </a:avLst>
+          </a:prstGeom>
+          <a:solidFill>
+            <a:srgbClr val="000000"/>
+          </a:solidFill>
+          <a:ln w="0">
+            <a:noFill/>
+          </a:ln>
+        </p:spPr>
+        <p:txBody>
+          <a:bodyPr anchor="ctr" anchorCtr="1"/>
+          <a:lstStyle/>
+          <a:p>
+            <a:pPr algn="ctr"/>
+            <a:r>
+              <a:rPr lang="es-CO" b="1" dirty="0">
+                <a:solidFill>
+                  <a:srgbClr val="FFFFFF"/>
+                </a:solidFill>
+                <a:sz val="1400"/>
+              </a:rPr>
+              <a:t>NEGRO</a:t>
+            </a:r>
+          </a:p>
+        </p:txBody>
+      </p:sp>
+      <p:sp>
+        <p:nvSpPr>
+          <p:cNvPr id="20" name="TextBox20"/>
+          <p:cNvSpPr txBox="1"/>
+          <p:nvPr/>
+        </p:nvSpPr>
+        <p:spPr>
+          <a:xfrm>
+            <a:off x="3600000" y="1728000"/>
+            <a:ext cx="7920000" cy="720000"/>
+          </a:xfrm>
+          <a:prstGeom prst="rect">
+            <a:avLst/>
+          </a:prstGeom>
+          <a:noFill/>
+        </p:spPr>
+        <p:txBody>
+          <a:bodyPr wrap="square" rtlCol="0"/>
+          <a:lstStyle/>
+          <a:p>
+            <a:pPr algn="l"/>
+            <a:r>
+              <a:rPr lang="es-CO" dirty="0">
+                <a:solidFill>
+                  <a:srgbClr val="404040"/>
+                </a:solidFill>
+                <a:sz val="1400"/>
+              </a:rPr>
+              <a:t>Fallecido - Sin respiracion</a:t>
+            </a:r>
+          </a:p>
+        </p:txBody>
+      </p:sp>
+      <p:sp>
+        <p:nvSpPr>
+          <p:cNvPr id="11" name="T1"/>
+          <p:cNvSpPr/>
+          <p:nvPr/>
+        </p:nvSpPr>
+        <p:spPr>
+          <a:xfrm>
+            <a:off x="360000" y="2627999"/>
+            <a:ext cx="2880000" cy="792000"/>
+          </a:xfrm>
+          <a:prstGeom prst="roundRect">
+            <a:avLst>
+              <a:gd name="adj" fmla="val 5000"/>
+            </a:avLst>
+          </a:prstGeom>
+          <a:solidFill>
+            <a:srgbClr val="C00000"/>
+          </a:solidFill>
+          <a:ln w="0">
+            <a:noFill/>
+          </a:ln>
+        </p:spPr>
+        <p:txBody>
+          <a:bodyPr anchor="ctr" anchorCtr="1"/>
+          <a:lstStyle/>
+          <a:p>
+            <a:pPr algn="ctr"/>
+            <a:r>
+              <a:rPr lang="es-CO" b="1" dirty="0">
+                <a:solidFill>
+                  <a:srgbClr val="FFFFFF"/>
+                </a:solidFill>
+                <a:sz val="1400"/>
+              </a:rPr>
+              <a:t>ROJO</a:t>
+            </a:r>
+          </a:p>
+        </p:txBody>
+      </p:sp>
+      <p:sp>
+        <p:nvSpPr>
+          <p:cNvPr id="21" name="TextBox21"/>
+          <p:cNvSpPr txBox="1"/>
+          <p:nvPr/>
+        </p:nvSpPr>
+        <p:spPr>
+          <a:xfrm>
+            <a:off x="3600000" y="2735999"/>
+            <a:ext cx="7920000" cy="720000"/>
+          </a:xfrm>
+          <a:prstGeom prst="rect">
+            <a:avLst/>
+          </a:prstGeom>
+          <a:noFill/>
+        </p:spPr>
+        <p:txBody>
+          <a:bodyPr wrap="square" rtlCol="0"/>
+          <a:lstStyle/>
+          <a:p>
+            <a:pPr algn="l"/>
+            <a:r>
+              <a:rPr lang="es-CO" dirty="0">
+                <a:solidFill>
+                  <a:srgbClr val="404040"/>
+                </a:solidFill>
+                <a:sz val="1400"/>
+              </a:rPr>
+              <a:t>Inmediato - Riesgo vital &lt; 60 min</a:t>
+            </a:r>
+          </a:p>
+        </p:txBody>
+      </p:sp>
+      <p:sp>
+        <p:nvSpPr>
+          <p:cNvPr id="12" name="T2"/>
+          <p:cNvSpPr/>
+          <p:nvPr/>
+        </p:nvSpPr>
+        <p:spPr>
+          <a:xfrm>
+            <a:off x="360000" y="3635998"/>
+            <a:ext cx="2880000" cy="792000"/>
+          </a:xfrm>
+          <a:prstGeom prst="roundRect">
+            <a:avLst>
+              <a:gd name="adj" fmla="val 5000"/>
+            </a:avLst>
+          </a:prstGeom>
+          <a:solidFill>
+            <a:srgbClr val="FFC000"/>
+          </a:solidFill>
+          <a:ln w="0">
+            <a:noFill/>
+          </a:ln>
+        </p:spPr>
+        <p:txBody>
+          <a:bodyPr anchor="ctr" anchorCtr="1"/>
+          <a:lstStyle/>
+          <a:p>
+            <a:pPr algn="ctr"/>
+            <a:r>
+              <a:rPr lang="es-CO" b="1" dirty="0">
+                <a:solidFill>
+                  <a:srgbClr val="000000"/>
+                </a:solidFill>
+                <a:sz val="1400"/>
+              </a:rPr>
+              <a:t>AMARILLO</a:t>
+            </a:r>
+          </a:p>
+        </p:txBody>
+      </p:sp>
+      <p:sp>
+        <p:nvSpPr>
+          <p:cNvPr id="22" name="TextBox22"/>
+          <p:cNvSpPr txBox="1"/>
+          <p:nvPr/>
+        </p:nvSpPr>
+        <p:spPr>
+          <a:xfrm>
+            <a:off x="3600000" y="3743998"/>
+            <a:ext cx="7920000" cy="720000"/>
+          </a:xfrm>
+          <a:prstGeom prst="rect">
+            <a:avLst/>
+          </a:prstGeom>
+          <a:noFill/>
+        </p:spPr>
+        <p:txBody>
+          <a:bodyPr wrap="square" rtlCol="0"/>
+          <a:lstStyle/>
+          <a:p>
+            <a:pPr algn="l"/>
+            <a:r>
+              <a:rPr lang="es-CO" dirty="0">
+                <a:solidFill>
+                  <a:srgbClr val="404040"/>
+                </a:solidFill>
+                <a:sz val="1400"/>
+              </a:rPr>
+              <a:t>Urgente - Serio pero estable</a:t>
+            </a:r>
+          </a:p>
+        </p:txBody>
+      </p:sp>
+      <p:sp>
+        <p:nvSpPr>
+          <p:cNvPr id="13" name="T3"/>
+          <p:cNvSpPr/>
+          <p:nvPr/>
+        </p:nvSpPr>
+        <p:spPr>
+          <a:xfrm>
+            <a:off x="360000" y="4643997"/>
+            <a:ext cx="2880000" cy="792000"/>
+          </a:xfrm>
+          <a:prstGeom prst="roundRect">
+            <a:avLst>
+              <a:gd name="adj" fmla="val 5000"/>
+            </a:avLst>
+          </a:prstGeom>
+          <a:solidFill>
+            <a:srgbClr val="70AD47"/>
+          </a:solidFill>
+          <a:ln w="0">
+            <a:noFill/>
+          </a:ln>
+        </p:spPr>
+        <p:txBody>
+          <a:bodyPr anchor="ctr" anchorCtr="1"/>
+          <a:lstStyle/>
+          <a:p>
+            <a:pPr algn="ctr"/>
+            <a:r>
+              <a:rPr lang="es-CO" b="1" dirty="0">
+                <a:solidFill>
+                  <a:srgbClr val="FFFFFF"/>
+                </a:solidFill>
+                <a:sz val="1400"/>
+              </a:rPr>
+              <a:t>VERDE</a:t>
+            </a:r>
+          </a:p>
+        </p:txBody>
+      </p:sp>
+      <p:sp>
+        <p:nvSpPr>
+          <p:cNvPr id="23" name="TextBox23"/>
+          <p:cNvSpPr txBox="1"/>
+          <p:nvPr/>
+        </p:nvSpPr>
+        <p:spPr>
+          <a:xfrm>
+            <a:off x="3600000" y="4751997"/>
+            <a:ext cx="7920000" cy="720000"/>
+          </a:xfrm>
+          <a:prstGeom prst="rect">
+            <a:avLst/>
+          </a:prstGeom>
+          <a:noFill/>
+        </p:spPr>
+        <p:txBody>
+          <a:bodyPr wrap="square" rtlCol="0"/>
+          <a:lstStyle/>
+          <a:p>
+            <a:pPr algn="l"/>
+            <a:r>
+              <a:rPr lang="es-CO" dirty="0">
+                <a:solidFill>
+                  <a:srgbClr val="404040"/>
+                </a:solidFill>
+                <a:sz val="1400"/>
+              </a:rPr>
+              <a:t>Menor - Camina, ambulatorio</a:t>
+            </a:r>
+          </a:p>
+        </p:txBody>
+      </p:sp>
     </p:spTree>
   </p:cSld>
 </p:sld>

</xml_diff>